<commit_message>
docs: update PPTX and Final Report attribution from IBM to Huvalon
- 13_Presentation.pptx: slide 1 + slide 12 footers updated
  IBM Student Project -> Huvalon Internship | Data Analysis & Automation
  Sayu-V | Yenepoya University | March 2026
  -> Sayooj Vandichal | Yenepoya University BCA | Mar-May 2026
- 12_Final_Report.docx: cover table, abstract, and running footer updated
  Author: Sayu (Sayu-V) -> Sayooj Vandichal (Sayu-V)
  Project: IBM Student Project 2023-2026 Batch
  -> Huvalon Consultancy Internship (Mar-May 2026)

Co-Authored-By: Claude Sonnet 4.6 <noreply@anthropic.com>
</commit_message>
<xml_diff>
--- a/docs/13_Presentation.pptx
+++ b/docs/13_Presentation.pptx
@@ -2065,7 +2065,7 @@
                 <a:ea typeface="Calibri" pitchFamily="34" charset="-122"/>
                 <a:cs typeface="Calibri" pitchFamily="34" charset="-120"/>
               </a:rPr>
-              <a:t>v2.3.0  |  IBM Student Project</a:t>
+              <a:t>v2.3.0  |  Huvalon Internship  |  Data Analysis &amp; Automation</a:t>
             </a:r>
             <a:endParaRPr lang="en-US" sz="1800" dirty="0"/>
           </a:p>
@@ -2399,7 +2399,7 @@
                 <a:ea typeface="Calibri" pitchFamily="34" charset="-122"/>
                 <a:cs typeface="Calibri" pitchFamily="34" charset="-120"/>
               </a:rPr>
-              <a:t>Sayu-V  |  Yenepoya University  |  March 2026</a:t>
+              <a:t>Sayooj Vandichal  |  Yenepoya University BCA  |  Mar – May 2026</a:t>
             </a:r>
             <a:endParaRPr lang="en-US" sz="1200" dirty="0"/>
           </a:p>
@@ -6438,7 +6438,7 @@
                 <a:ea typeface="Calibri" pitchFamily="34" charset="-122"/>
                 <a:cs typeface="Calibri" pitchFamily="34" charset="-120"/>
               </a:rPr>
-              <a:t>Expense Tracker v2.3.0  |  IBM Student Project</a:t>
+              <a:t>Expense Tracker v2.3.0  |  Huvalon Internship  |  Data Analysis &amp; Automation</a:t>
             </a:r>
             <a:endParaRPr lang="en-US" sz="1700" dirty="0"/>
           </a:p>
@@ -6797,7 +6797,7 @@
                 <a:ea typeface="Calibri" pitchFamily="34" charset="-122"/>
                 <a:cs typeface="Calibri" pitchFamily="34" charset="-120"/>
               </a:rPr>
-              <a:t>Sayu-V  |  Yenepoya University  |  github.com/Sayu-V/expense-tracker  |  March 2026</a:t>
+              <a:t>Sayooj Vandichal  |  Yenepoya University BCA  |  github.com/Sayu-V/expense-tracker  |  Mar – May 2026</a:t>
             </a:r>
             <a:endParaRPr lang="en-US" sz="1100" dirty="0"/>
           </a:p>

</xml_diff>